<commit_message>
Las slides recogen las cifras nuevas: 205 tests y contrato 1.8.0
El cierre de la lectura de documentos (ff88964) añadió dos tests y subió el
contrato a la 1.8.0, y la presentación seguía diciendo 203 y 1.7.0 en las
diapositivas de despliegue y cierre. Solo cambian esas dos cifras.

Co-Authored-By: Claude Opus 5 <noreply@anthropic.com>
</commit_message>
<xml_diff>
--- a/docs/AgentPilot_Presentación.pptx
+++ b/docs/AgentPilot_Presentación.pptx
@@ -10315,7 +10315,7 @@
                 <a:ea typeface="Segoe UI" pitchFamily="34" charset="-122"/>
                 <a:cs typeface="Segoe UI" pitchFamily="34" charset="-120"/>
               </a:rPr>
-              <a:t>github.com/camilorkll/AgentPilot — 20 ADR, contrato OpenAPI y 203 tests automatizados.</a:t>
+              <a:t>github.com/camilorkll/AgentPilot — 20 ADR, contrato OpenAPI y 205 tests automatizados.</a:t>
             </a:r>
             <a:endParaRPr lang="en-US" sz="1000" dirty="0"/>
           </a:p>
@@ -10908,7 +10908,7 @@
                 <a:ea typeface="Segoe UI" pitchFamily="34" charset="-122"/>
                 <a:cs typeface="Segoe UI" pitchFamily="34" charset="-120"/>
               </a:rPr>
-              <a:t>203</a:t>
+              <a:t>205</a:t>
             </a:r>
             <a:endParaRPr lang="en-US" sz="4000" dirty="0"/>
           </a:p>
@@ -11052,7 +11052,7 @@
                 <a:ea typeface="Segoe UI" pitchFamily="34" charset="-122"/>
                 <a:cs typeface="Segoe UI" pitchFamily="34" charset="-120"/>
               </a:rPr>
-              <a:t>1.7.0</a:t>
+              <a:t>1.8.0</a:t>
             </a:r>
             <a:endParaRPr lang="en-US" sz="4000" dirty="0"/>
           </a:p>

</xml_diff>